<commit_message>
Mostra só as imagens do projeto e tira os números da meta de produção
- Os slides de antes e depois viram slides do projeto em tela cheia, sem
  as fotos reais (index.html, patrocinio.html e PPT)
- O slide A casa usa as imagens do projeto
- Meta de produção e vendas fica só com texto: etapas e indicadores, sem
  valores

Co-Authored-By: Claude Opus 5.5 <noreply@anthropic.com>
Claude-Session: https://claude.ai/code/session_018hcdayTmVfNXjxRbvnZFh5
</commit_message>
<xml_diff>
--- a/Bhe-Cota-de-Patrocinio.pptx
+++ b/Bhe-Cota-de-Patrocinio.pptx
@@ -119,14 +119,14 @@
   <p:extLst>
     <p:ext uri="{521415D9-36F7-43E2-AB2F-B90AF26B5E84}">
       <p14:sectionLst xmlns:p14="http://schemas.microsoft.com/office/powerpoint/2010/main">
-        <p14:section name="Abertura" id="{2d72b8cc-6155-8235-de2e-975699c98a02}">
+        <p14:section name="Abertura" id="{ea67eef3-4633-40f9-4077-044f7b919547}">
           <p14:sldIdLst>
             <p14:sldId id="256"/>
             <p14:sldId id="257"/>
             <p14:sldId id="258"/>
           </p14:sldIdLst>
         </p14:section>
-        <p14:section name="Antes e depois" id="{d9bd0f17-3e25-7942-1f29-107a43e6f9f9}">
+        <p14:section name="O projeto" id="{768d3507-3496-1c03-20f6-3a9cec3a59ba}">
           <p14:sldIdLst>
             <p14:sldId id="259"/>
             <p14:sldId id="260"/>
@@ -135,13 +135,13 @@
             <p14:sldId id="263"/>
           </p14:sldIdLst>
         </p14:section>
-        <p14:section name="Alcance" id="{a1559df1-c5f6-1324-0ec8-302cfbf087e6}">
+        <p14:section name="Alcance" id="{7084b5d4-9cad-fefc-b4af-fa4462976038}">
           <p14:sldIdLst>
             <p14:sldId id="264"/>
             <p14:sldId id="265"/>
           </p14:sldIdLst>
         </p14:section>
-        <p14:section name="Proposta" id="{259ca983-10e3-faa9-54fd-bb0857ebd28f}">
+        <p14:section name="Proposta" id="{b5e1a526-5e2a-8940-b051-f406a4bce841}">
           <p14:sldIdLst>
             <p14:sldId id="266"/>
             <p14:sldId id="267"/>
@@ -2125,11 +2125,11 @@
 
 <file path=ppt/slideLayouts/slideLayout6.xml><?xml version="1.0" encoding="utf-8"?>
 <p:sldLayout xmlns:a="http://schemas.openxmlformats.org/drawingml/2006/main" xmlns:r="http://schemas.openxmlformats.org/officeDocument/2006/relationships" xmlns:p="http://schemas.openxmlformats.org/presentationml/2006/main" preserve="1">
-  <p:cSld name="Antes e depois">
+  <p:cSld name="Projeto">
     <p:bg>
       <p:bgPr>
         <a:solidFill>
-          <a:schemeClr val="bg1"/>
+          <a:schemeClr val="tx1"/>
         </a:solidFill>
       </p:bgPr>
     </p:bg>
@@ -2157,8 +2157,8 @@
         </p:nvSpPr>
         <p:spPr>
           <a:xfrm>
-            <a:off x="4450080" y="4937760"/>
-            <a:ext cx="6949440" cy="182880"/>
+            <a:off x="792480" y="5151120"/>
+            <a:ext cx="7620000" cy="182880"/>
           </a:xfrm>
           <a:prstGeom prst="rect">
             <a:avLst/>
@@ -2173,7 +2173,7 @@
               <a:buNone/>
               <a:defRPr lang="en-US" sz="1000" spc="400" kern="0" dirty="0">
                 <a:solidFill>
-                  <a:schemeClr val="accent2"/>
+                  <a:schemeClr val="accent6"/>
                 </a:solidFill>
               </a:defRPr>
             </a:lvl1pPr>
@@ -2196,8 +2196,8 @@
         </p:nvSpPr>
         <p:spPr>
           <a:xfrm>
-            <a:off x="4450080" y="5181600"/>
-            <a:ext cx="6949440" cy="487680"/>
+            <a:off x="792480" y="5425440"/>
+            <a:ext cx="7620000" cy="548640"/>
           </a:xfrm>
           <a:prstGeom prst="rect">
             <a:avLst/>
@@ -2210,9 +2210,9 @@
           <a:lstStyle>
             <a:lvl1pPr algn="l" indent="0" marL="0">
               <a:buNone/>
-              <a:defRPr lang="en-US" sz="3200" dirty="0">
-                <a:solidFill>
-                  <a:schemeClr val="tx1"/>
+              <a:defRPr lang="en-US" sz="4000" dirty="0">
+                <a:solidFill>
+                  <a:schemeClr val="bg1"/>
                 </a:solidFill>
                 <a:latin typeface="Cambria" pitchFamily="34" charset="0"/>
                 <a:ea typeface="Cambria" pitchFamily="34" charset="-122"/>
@@ -2224,7 +2224,7 @@
             <a:pPr algn="l" indent="0" marL="0">
               <a:buNone/>
             </a:pPr>
-            <a:endParaRPr lang="en-US" sz="3200" dirty="0"/>
+            <a:endParaRPr lang="en-US" sz="4000" dirty="0"/>
           </a:p>
         </p:txBody>
       </p:sp>
@@ -5115,7 +5115,7 @@
       </p:grpSpPr>
       <p:pic>
         <p:nvPicPr>
-          <p:cNvPr id="2" name="Vitrine de marcas: foto real hoje" descr="Vitrine de marcas: foto real hoje">    </p:cNvPr>
+          <p:cNvPr id="2" name="Vitrine de marcas: projeto de ambientação" descr="Vitrine de marcas: projeto de ambientação">    </p:cNvPr>
           <p:cNvPicPr>
             <a:picLocks noChangeAspect="1"/>
           </p:cNvPicPr>
@@ -5130,7 +5130,7 @@
         <p:spPr>
           <a:xfrm>
             <a:off x="0" y="0"/>
-            <a:ext cx="3962400" cy="6858000"/>
+            <a:ext cx="12192000" cy="6858000"/>
           </a:xfrm>
           <a:prstGeom prst="rect">
             <a:avLst/>
@@ -5139,176 +5139,94 @@
       </p:pic>
       <p:sp>
         <p:nvSpPr>
-          <p:cNvPr id="3" name="Etiqueta"/>
-          <p:cNvSpPr txBox="1"/>
-          <p:nvPr/>
-        </p:nvSpPr>
-        <p:spPr>
-          <a:xfrm>
-            <a:off x="243840" y="6370320"/>
-            <a:ext cx="1828800" cy="243840"/>
+          <p:cNvPr id="3" name="Sombra do texto"/>
+          <p:cNvSpPr/>
+          <p:nvPr/>
+        </p:nvSpPr>
+        <p:spPr>
+          <a:xfrm>
+            <a:off x="0" y="4876800"/>
+            <a:ext cx="12192000" cy="1981200"/>
           </a:xfrm>
           <a:prstGeom prst="rect">
             <a:avLst/>
           </a:prstGeom>
           <a:solidFill>
             <a:schemeClr val="tx1">
-              <a:alpha val="60000"/>
+              <a:alpha val="70000"/>
             </a:schemeClr>
           </a:solidFill>
           <a:ln/>
         </p:spPr>
-        <p:txBody>
-          <a:bodyPr wrap="square" lIns="0" tIns="101600" rIns="101600" bIns="0" rtlCol="0" anchor="ctr"/>
-          <a:lstStyle/>
-          <a:p>
-            <a:pPr indent="0" marL="0">
-              <a:buNone/>
-            </a:pPr>
-            <a:r>
-              <a:rPr lang="en-US" sz="800" spc="200" kern="0" dirty="0">
+      </p:sp>
+      <p:sp>
+        <p:nvSpPr>
+          <p:cNvPr id="4" name="Text 0"/>
+          <p:cNvSpPr/>
+          <p:nvPr>
+            <p:ph idx="100" type="body" hasCustomPrompt="1"/>
+          </p:nvPr>
+        </p:nvSpPr>
+        <p:spPr>
+          <a:xfrm>
+            <a:off x="792480" y="5151120"/>
+            <a:ext cx="7620000" cy="182880"/>
+          </a:xfrm>
+          <a:prstGeom prst="rect">
+            <a:avLst/>
+          </a:prstGeom>
+          <a:noFill/>
+          <a:ln/>
+        </p:spPr>
+        <p:txBody>
+          <a:bodyPr wrap="square" lIns="0" tIns="0" rIns="0" bIns="0" rtlCol="0" anchor="t"/>
+          <a:lstStyle/>
+          <a:p>
+            <a:pPr algn="l" indent="0" marL="0">
+              <a:buNone/>
+            </a:pPr>
+            <a:r>
+              <a:rPr lang="en-US" sz="1000" spc="400" kern="0" dirty="0">
+                <a:solidFill>
+                  <a:schemeClr val="accent6"/>
+                </a:solidFill>
+              </a:rPr>
+              <a:t>O PROJETO · 01 / 05</a:t>
+            </a:r>
+            <a:endParaRPr lang="en-US" sz="1000" dirty="0"/>
+          </a:p>
+        </p:txBody>
+      </p:sp>
+      <p:sp>
+        <p:nvSpPr>
+          <p:cNvPr id="5" name="Text 0"/>
+          <p:cNvSpPr/>
+          <p:nvPr>
+            <p:ph idx="101" type="title" hasCustomPrompt="1"/>
+          </p:nvPr>
+        </p:nvSpPr>
+        <p:spPr>
+          <a:xfrm>
+            <a:off x="792480" y="5425440"/>
+            <a:ext cx="7620000" cy="548640"/>
+          </a:xfrm>
+          <a:prstGeom prst="rect">
+            <a:avLst/>
+          </a:prstGeom>
+          <a:noFill/>
+          <a:ln/>
+        </p:spPr>
+        <p:txBody>
+          <a:bodyPr wrap="square" lIns="0" tIns="0" rIns="0" bIns="0" rtlCol="0" anchor="t"/>
+          <a:lstStyle/>
+          <a:p>
+            <a:pPr algn="l" indent="0" marL="0">
+              <a:buNone/>
+            </a:pPr>
+            <a:r>
+              <a:rPr lang="en-US" sz="4000" dirty="0">
                 <a:solidFill>
                   <a:schemeClr val="bg1"/>
-                </a:solidFill>
-              </a:rPr>
-              <a:t>HOJE · FOTO REAL</a:t>
-            </a:r>
-            <a:endParaRPr lang="en-US" sz="800" dirty="0"/>
-          </a:p>
-        </p:txBody>
-      </p:sp>
-      <p:pic>
-        <p:nvPicPr>
-          <p:cNvPr id="4" name="Vitrine de marcas: proposta de ambientação" descr="Vitrine de marcas: proposta de ambientação">    </p:cNvPr>
-          <p:cNvPicPr>
-            <a:picLocks noChangeAspect="1"/>
-          </p:cNvPicPr>
-          <p:nvPr/>
-        </p:nvPicPr>
-        <p:blipFill>
-          <a:blip r:embed="rId2"/>
-          <a:stretch>
-            <a:fillRect/>
-          </a:stretch>
-        </p:blipFill>
-        <p:spPr>
-          <a:xfrm>
-            <a:off x="4450080" y="670560"/>
-            <a:ext cx="6949440" cy="3909060"/>
-          </a:xfrm>
-          <a:prstGeom prst="rect">
-            <a:avLst/>
-          </a:prstGeom>
-        </p:spPr>
-      </p:pic>
-      <p:sp>
-        <p:nvSpPr>
-          <p:cNvPr id="5" name="Etiqueta"/>
-          <p:cNvSpPr txBox="1"/>
-          <p:nvPr/>
-        </p:nvSpPr>
-        <p:spPr>
-          <a:xfrm>
-            <a:off x="4632960" y="4244340"/>
-            <a:ext cx="3017520" cy="243840"/>
-          </a:xfrm>
-          <a:prstGeom prst="rect">
-            <a:avLst/>
-          </a:prstGeom>
-          <a:solidFill>
-            <a:schemeClr val="tx1">
-              <a:alpha val="60000"/>
-            </a:schemeClr>
-          </a:solidFill>
-          <a:ln/>
-        </p:spPr>
-        <p:txBody>
-          <a:bodyPr wrap="square" lIns="0" tIns="101600" rIns="101600" bIns="0" rtlCol="0" anchor="ctr"/>
-          <a:lstStyle/>
-          <a:p>
-            <a:pPr indent="0" marL="0">
-              <a:buNone/>
-            </a:pPr>
-            <a:r>
-              <a:rPr lang="en-US" sz="800" spc="200" kern="0" dirty="0">
-                <a:solidFill>
-                  <a:schemeClr val="bg1"/>
-                </a:solidFill>
-              </a:rPr>
-              <a:t>PROPOSTA · IMAGEM ILUSTRATIVA</a:t>
-            </a:r>
-            <a:endParaRPr lang="en-US" sz="800" dirty="0"/>
-          </a:p>
-        </p:txBody>
-      </p:sp>
-      <p:sp>
-        <p:nvSpPr>
-          <p:cNvPr id="6" name="Text 0"/>
-          <p:cNvSpPr/>
-          <p:nvPr>
-            <p:ph idx="100" type="body" hasCustomPrompt="1"/>
-          </p:nvPr>
-        </p:nvSpPr>
-        <p:spPr>
-          <a:xfrm>
-            <a:off x="4450080" y="4937760"/>
-            <a:ext cx="6949440" cy="182880"/>
-          </a:xfrm>
-          <a:prstGeom prst="rect">
-            <a:avLst/>
-          </a:prstGeom>
-          <a:noFill/>
-          <a:ln/>
-        </p:spPr>
-        <p:txBody>
-          <a:bodyPr wrap="square" lIns="0" tIns="0" rIns="0" bIns="0" rtlCol="0" anchor="t"/>
-          <a:lstStyle/>
-          <a:p>
-            <a:pPr algn="l" indent="0" marL="0">
-              <a:buNone/>
-            </a:pPr>
-            <a:r>
-              <a:rPr lang="en-US" sz="1000" spc="400" kern="0" dirty="0">
-                <a:solidFill>
-                  <a:schemeClr val="accent2"/>
-                </a:solidFill>
-              </a:rPr>
-              <a:t>ANTES E DEPOIS · 01 / 05</a:t>
-            </a:r>
-            <a:endParaRPr lang="en-US" sz="1000" dirty="0"/>
-          </a:p>
-        </p:txBody>
-      </p:sp>
-      <p:sp>
-        <p:nvSpPr>
-          <p:cNvPr id="7" name="Text 0"/>
-          <p:cNvSpPr/>
-          <p:nvPr>
-            <p:ph idx="101" type="title" hasCustomPrompt="1"/>
-          </p:nvPr>
-        </p:nvSpPr>
-        <p:spPr>
-          <a:xfrm>
-            <a:off x="4450080" y="5181600"/>
-            <a:ext cx="6949440" cy="487680"/>
-          </a:xfrm>
-          <a:prstGeom prst="rect">
-            <a:avLst/>
-          </a:prstGeom>
-          <a:noFill/>
-          <a:ln/>
-        </p:spPr>
-        <p:txBody>
-          <a:bodyPr wrap="square" lIns="0" tIns="0" rIns="0" bIns="0" rtlCol="0" anchor="t"/>
-          <a:lstStyle/>
-          <a:p>
-            <a:pPr algn="l" indent="0" marL="0">
-              <a:buNone/>
-            </a:pPr>
-            <a:r>
-              <a:rPr lang="en-US" sz="3200" dirty="0">
-                <a:solidFill>
-                  <a:schemeClr val="tx1"/>
                 </a:solidFill>
                 <a:latin typeface="Cambria" pitchFamily="34" charset="0"/>
                 <a:ea typeface="Cambria" pitchFamily="34" charset="-122"/>
@@ -5316,20 +5234,20 @@
               </a:rPr>
               <a:t>Vitrine de marcas</a:t>
             </a:r>
-            <a:endParaRPr lang="en-US" sz="3200" dirty="0"/>
-          </a:p>
-        </p:txBody>
-      </p:sp>
-      <p:sp>
-        <p:nvSpPr>
-          <p:cNvPr id="8" name="Descrição"/>
+            <a:endParaRPr lang="en-US" sz="4000" dirty="0"/>
+          </a:p>
+        </p:txBody>
+      </p:sp>
+      <p:sp>
+        <p:nvSpPr>
+          <p:cNvPr id="6" name="Descrição"/>
           <p:cNvSpPr txBox="1"/>
           <p:nvPr/>
         </p:nvSpPr>
         <p:spPr>
           <a:xfrm>
-            <a:off x="4450080" y="5730240"/>
-            <a:ext cx="6705600" cy="609600"/>
+            <a:off x="792480" y="6035040"/>
+            <a:ext cx="7620000" cy="457200"/>
           </a:xfrm>
           <a:prstGeom prst="rect">
             <a:avLst/>
@@ -5347,12 +5265,48 @@
             <a:r>
               <a:rPr lang="en-US" sz="1500" dirty="0">
                 <a:solidFill>
-                  <a:schemeClr val="tx2"/>
+                  <a:schemeClr val="bg1"/>
                 </a:solidFill>
               </a:rPr>
               <a:t>O painel de madeira e a estante recebem iluminação, produtos e o logo da Bhe. É onde fica o espaço exclusivo do patrocinador.</a:t>
             </a:r>
             <a:endParaRPr lang="en-US" sz="1500" dirty="0"/>
+          </a:p>
+        </p:txBody>
+      </p:sp>
+      <p:sp>
+        <p:nvSpPr>
+          <p:cNvPr id="7" name="Aviso"/>
+          <p:cNvSpPr txBox="1"/>
+          <p:nvPr/>
+        </p:nvSpPr>
+        <p:spPr>
+          <a:xfrm>
+            <a:off x="9113520" y="6248400"/>
+            <a:ext cx="2286000" cy="182880"/>
+          </a:xfrm>
+          <a:prstGeom prst="rect">
+            <a:avLst/>
+          </a:prstGeom>
+          <a:noFill/>
+          <a:ln/>
+        </p:spPr>
+        <p:txBody>
+          <a:bodyPr wrap="square" lIns="0" tIns="0" rIns="0" bIns="0" rtlCol="0" anchor="ctr"/>
+          <a:lstStyle/>
+          <a:p>
+            <a:pPr algn="r" indent="0" marL="0">
+              <a:buNone/>
+            </a:pPr>
+            <a:r>
+              <a:rPr lang="en-US" sz="1000" dirty="0">
+                <a:solidFill>
+                  <a:schemeClr val="accent6"/>
+                </a:solidFill>
+              </a:rPr>
+              <a:t>Imagem ilustrativa do projeto</a:t>
+            </a:r>
+            <a:endParaRPr lang="en-US" sz="1000" dirty="0"/>
           </a:p>
         </p:txBody>
       </p:sp>
@@ -5383,7 +5337,7 @@
       </p:grpSpPr>
       <p:pic>
         <p:nvPicPr>
-          <p:cNvPr id="2" name="Estúdio de lives: foto real hoje" descr="Estúdio de lives: foto real hoje">    </p:cNvPr>
+          <p:cNvPr id="2" name="Estúdio de lives: projeto de ambientação" descr="Estúdio de lives: projeto de ambientação">    </p:cNvPr>
           <p:cNvPicPr>
             <a:picLocks noChangeAspect="1"/>
           </p:cNvPicPr>
@@ -5398,7 +5352,7 @@
         <p:spPr>
           <a:xfrm>
             <a:off x="0" y="0"/>
-            <a:ext cx="3962400" cy="6858000"/>
+            <a:ext cx="12192000" cy="6858000"/>
           </a:xfrm>
           <a:prstGeom prst="rect">
             <a:avLst/>
@@ -5407,176 +5361,94 @@
       </p:pic>
       <p:sp>
         <p:nvSpPr>
-          <p:cNvPr id="3" name="Etiqueta"/>
-          <p:cNvSpPr txBox="1"/>
-          <p:nvPr/>
-        </p:nvSpPr>
-        <p:spPr>
-          <a:xfrm>
-            <a:off x="243840" y="6370320"/>
-            <a:ext cx="1828800" cy="243840"/>
+          <p:cNvPr id="3" name="Sombra do texto"/>
+          <p:cNvSpPr/>
+          <p:nvPr/>
+        </p:nvSpPr>
+        <p:spPr>
+          <a:xfrm>
+            <a:off x="0" y="4876800"/>
+            <a:ext cx="12192000" cy="1981200"/>
           </a:xfrm>
           <a:prstGeom prst="rect">
             <a:avLst/>
           </a:prstGeom>
           <a:solidFill>
             <a:schemeClr val="tx1">
-              <a:alpha val="60000"/>
+              <a:alpha val="70000"/>
             </a:schemeClr>
           </a:solidFill>
           <a:ln/>
         </p:spPr>
-        <p:txBody>
-          <a:bodyPr wrap="square" lIns="0" tIns="101600" rIns="101600" bIns="0" rtlCol="0" anchor="ctr"/>
-          <a:lstStyle/>
-          <a:p>
-            <a:pPr indent="0" marL="0">
-              <a:buNone/>
-            </a:pPr>
-            <a:r>
-              <a:rPr lang="en-US" sz="800" spc="200" kern="0" dirty="0">
+      </p:sp>
+      <p:sp>
+        <p:nvSpPr>
+          <p:cNvPr id="4" name="Text 0"/>
+          <p:cNvSpPr/>
+          <p:nvPr>
+            <p:ph idx="100" type="body" hasCustomPrompt="1"/>
+          </p:nvPr>
+        </p:nvSpPr>
+        <p:spPr>
+          <a:xfrm>
+            <a:off x="792480" y="5151120"/>
+            <a:ext cx="7620000" cy="182880"/>
+          </a:xfrm>
+          <a:prstGeom prst="rect">
+            <a:avLst/>
+          </a:prstGeom>
+          <a:noFill/>
+          <a:ln/>
+        </p:spPr>
+        <p:txBody>
+          <a:bodyPr wrap="square" lIns="0" tIns="0" rIns="0" bIns="0" rtlCol="0" anchor="t"/>
+          <a:lstStyle/>
+          <a:p>
+            <a:pPr algn="l" indent="0" marL="0">
+              <a:buNone/>
+            </a:pPr>
+            <a:r>
+              <a:rPr lang="en-US" sz="1000" spc="400" kern="0" dirty="0">
+                <a:solidFill>
+                  <a:schemeClr val="accent6"/>
+                </a:solidFill>
+              </a:rPr>
+              <a:t>O PROJETO · 02 / 05</a:t>
+            </a:r>
+            <a:endParaRPr lang="en-US" sz="1000" dirty="0"/>
+          </a:p>
+        </p:txBody>
+      </p:sp>
+      <p:sp>
+        <p:nvSpPr>
+          <p:cNvPr id="5" name="Text 0"/>
+          <p:cNvSpPr/>
+          <p:nvPr>
+            <p:ph idx="101" type="title" hasCustomPrompt="1"/>
+          </p:nvPr>
+        </p:nvSpPr>
+        <p:spPr>
+          <a:xfrm>
+            <a:off x="792480" y="5425440"/>
+            <a:ext cx="7620000" cy="548640"/>
+          </a:xfrm>
+          <a:prstGeom prst="rect">
+            <a:avLst/>
+          </a:prstGeom>
+          <a:noFill/>
+          <a:ln/>
+        </p:spPr>
+        <p:txBody>
+          <a:bodyPr wrap="square" lIns="0" tIns="0" rIns="0" bIns="0" rtlCol="0" anchor="t"/>
+          <a:lstStyle/>
+          <a:p>
+            <a:pPr algn="l" indent="0" marL="0">
+              <a:buNone/>
+            </a:pPr>
+            <a:r>
+              <a:rPr lang="en-US" sz="4000" dirty="0">
                 <a:solidFill>
                   <a:schemeClr val="bg1"/>
-                </a:solidFill>
-              </a:rPr>
-              <a:t>HOJE · FOTO REAL</a:t>
-            </a:r>
-            <a:endParaRPr lang="en-US" sz="800" dirty="0"/>
-          </a:p>
-        </p:txBody>
-      </p:sp>
-      <p:pic>
-        <p:nvPicPr>
-          <p:cNvPr id="4" name="Estúdio de lives: proposta de ambientação" descr="Estúdio de lives: proposta de ambientação">    </p:cNvPr>
-          <p:cNvPicPr>
-            <a:picLocks noChangeAspect="1"/>
-          </p:cNvPicPr>
-          <p:nvPr/>
-        </p:nvPicPr>
-        <p:blipFill>
-          <a:blip r:embed="rId2"/>
-          <a:stretch>
-            <a:fillRect/>
-          </a:stretch>
-        </p:blipFill>
-        <p:spPr>
-          <a:xfrm>
-            <a:off x="4450080" y="670560"/>
-            <a:ext cx="6949440" cy="3909060"/>
-          </a:xfrm>
-          <a:prstGeom prst="rect">
-            <a:avLst/>
-          </a:prstGeom>
-        </p:spPr>
-      </p:pic>
-      <p:sp>
-        <p:nvSpPr>
-          <p:cNvPr id="5" name="Etiqueta"/>
-          <p:cNvSpPr txBox="1"/>
-          <p:nvPr/>
-        </p:nvSpPr>
-        <p:spPr>
-          <a:xfrm>
-            <a:off x="4632960" y="4244340"/>
-            <a:ext cx="3017520" cy="243840"/>
-          </a:xfrm>
-          <a:prstGeom prst="rect">
-            <a:avLst/>
-          </a:prstGeom>
-          <a:solidFill>
-            <a:schemeClr val="tx1">
-              <a:alpha val="60000"/>
-            </a:schemeClr>
-          </a:solidFill>
-          <a:ln/>
-        </p:spPr>
-        <p:txBody>
-          <a:bodyPr wrap="square" lIns="0" tIns="101600" rIns="101600" bIns="0" rtlCol="0" anchor="ctr"/>
-          <a:lstStyle/>
-          <a:p>
-            <a:pPr indent="0" marL="0">
-              <a:buNone/>
-            </a:pPr>
-            <a:r>
-              <a:rPr lang="en-US" sz="800" spc="200" kern="0" dirty="0">
-                <a:solidFill>
-                  <a:schemeClr val="bg1"/>
-                </a:solidFill>
-              </a:rPr>
-              <a:t>PROPOSTA · IMAGEM ILUSTRATIVA</a:t>
-            </a:r>
-            <a:endParaRPr lang="en-US" sz="800" dirty="0"/>
-          </a:p>
-        </p:txBody>
-      </p:sp>
-      <p:sp>
-        <p:nvSpPr>
-          <p:cNvPr id="6" name="Text 0"/>
-          <p:cNvSpPr/>
-          <p:nvPr>
-            <p:ph idx="100" type="body" hasCustomPrompt="1"/>
-          </p:nvPr>
-        </p:nvSpPr>
-        <p:spPr>
-          <a:xfrm>
-            <a:off x="4450080" y="4937760"/>
-            <a:ext cx="6949440" cy="182880"/>
-          </a:xfrm>
-          <a:prstGeom prst="rect">
-            <a:avLst/>
-          </a:prstGeom>
-          <a:noFill/>
-          <a:ln/>
-        </p:spPr>
-        <p:txBody>
-          <a:bodyPr wrap="square" lIns="0" tIns="0" rIns="0" bIns="0" rtlCol="0" anchor="t"/>
-          <a:lstStyle/>
-          <a:p>
-            <a:pPr algn="l" indent="0" marL="0">
-              <a:buNone/>
-            </a:pPr>
-            <a:r>
-              <a:rPr lang="en-US" sz="1000" spc="400" kern="0" dirty="0">
-                <a:solidFill>
-                  <a:schemeClr val="accent2"/>
-                </a:solidFill>
-              </a:rPr>
-              <a:t>ANTES E DEPOIS · 02 / 05</a:t>
-            </a:r>
-            <a:endParaRPr lang="en-US" sz="1000" dirty="0"/>
-          </a:p>
-        </p:txBody>
-      </p:sp>
-      <p:sp>
-        <p:nvSpPr>
-          <p:cNvPr id="7" name="Text 0"/>
-          <p:cNvSpPr/>
-          <p:nvPr>
-            <p:ph idx="101" type="title" hasCustomPrompt="1"/>
-          </p:nvPr>
-        </p:nvSpPr>
-        <p:spPr>
-          <a:xfrm>
-            <a:off x="4450080" y="5181600"/>
-            <a:ext cx="6949440" cy="487680"/>
-          </a:xfrm>
-          <a:prstGeom prst="rect">
-            <a:avLst/>
-          </a:prstGeom>
-          <a:noFill/>
-          <a:ln/>
-        </p:spPr>
-        <p:txBody>
-          <a:bodyPr wrap="square" lIns="0" tIns="0" rIns="0" bIns="0" rtlCol="0" anchor="t"/>
-          <a:lstStyle/>
-          <a:p>
-            <a:pPr algn="l" indent="0" marL="0">
-              <a:buNone/>
-            </a:pPr>
-            <a:r>
-              <a:rPr lang="en-US" sz="3200" dirty="0">
-                <a:solidFill>
-                  <a:schemeClr val="tx1"/>
                 </a:solidFill>
                 <a:latin typeface="Cambria" pitchFamily="34" charset="0"/>
                 <a:ea typeface="Cambria" pitchFamily="34" charset="-122"/>
@@ -5584,20 +5456,20 @@
               </a:rPr>
               <a:t>Estúdio de lives</a:t>
             </a:r>
-            <a:endParaRPr lang="en-US" sz="3200" dirty="0"/>
-          </a:p>
-        </p:txBody>
-      </p:sp>
-      <p:sp>
-        <p:nvSpPr>
-          <p:cNvPr id="8" name="Descrição"/>
+            <a:endParaRPr lang="en-US" sz="4000" dirty="0"/>
+          </a:p>
+        </p:txBody>
+      </p:sp>
+      <p:sp>
+        <p:nvSpPr>
+          <p:cNvPr id="6" name="Descrição"/>
           <p:cNvSpPr txBox="1"/>
           <p:nvPr/>
         </p:nvSpPr>
         <p:spPr>
           <a:xfrm>
-            <a:off x="4450080" y="5730240"/>
-            <a:ext cx="6705600" cy="609600"/>
+            <a:off x="792480" y="6035040"/>
+            <a:ext cx="7620000" cy="457200"/>
           </a:xfrm>
           <a:prstGeom prst="rect">
             <a:avLst/>
@@ -5615,12 +5487,48 @@
             <a:r>
               <a:rPr lang="en-US" sz="1500" dirty="0">
                 <a:solidFill>
-                  <a:schemeClr val="tx2"/>
-                </a:solidFill>
-              </a:rPr>
-              <a:t>O lounge vira bancada de maquiagem com iluminação de estúdio, câmera e vitrine de produtos ao fundo.</a:t>
+                  <a:schemeClr val="bg1"/>
+                </a:solidFill>
+              </a:rPr>
+              <a:t>Bancada de maquiagem com iluminação de estúdio, câmera e vitrine de produtos ao fundo.</a:t>
             </a:r>
             <a:endParaRPr lang="en-US" sz="1500" dirty="0"/>
+          </a:p>
+        </p:txBody>
+      </p:sp>
+      <p:sp>
+        <p:nvSpPr>
+          <p:cNvPr id="7" name="Aviso"/>
+          <p:cNvSpPr txBox="1"/>
+          <p:nvPr/>
+        </p:nvSpPr>
+        <p:spPr>
+          <a:xfrm>
+            <a:off x="9113520" y="6248400"/>
+            <a:ext cx="2286000" cy="182880"/>
+          </a:xfrm>
+          <a:prstGeom prst="rect">
+            <a:avLst/>
+          </a:prstGeom>
+          <a:noFill/>
+          <a:ln/>
+        </p:spPr>
+        <p:txBody>
+          <a:bodyPr wrap="square" lIns="0" tIns="0" rIns="0" bIns="0" rtlCol="0" anchor="ctr"/>
+          <a:lstStyle/>
+          <a:p>
+            <a:pPr algn="r" indent="0" marL="0">
+              <a:buNone/>
+            </a:pPr>
+            <a:r>
+              <a:rPr lang="en-US" sz="1000" dirty="0">
+                <a:solidFill>
+                  <a:schemeClr val="accent6"/>
+                </a:solidFill>
+              </a:rPr>
+              <a:t>Imagem ilustrativa do projeto</a:t>
+            </a:r>
+            <a:endParaRPr lang="en-US" sz="1000" dirty="0"/>
           </a:p>
         </p:txBody>
       </p:sp>
@@ -5651,7 +5559,7 @@
       </p:grpSpPr>
       <p:pic>
         <p:nvPicPr>
-          <p:cNvPr id="2" name="Estúdio de entrevistas: foto real hoje" descr="Estúdio de entrevistas: foto real hoje">    </p:cNvPr>
+          <p:cNvPr id="2" name="Estúdio de entrevistas: projeto de ambientação" descr="Estúdio de entrevistas: projeto de ambientação">    </p:cNvPr>
           <p:cNvPicPr>
             <a:picLocks noChangeAspect="1"/>
           </p:cNvPicPr>
@@ -5666,7 +5574,7 @@
         <p:spPr>
           <a:xfrm>
             <a:off x="0" y="0"/>
-            <a:ext cx="3962400" cy="6858000"/>
+            <a:ext cx="12192000" cy="6858000"/>
           </a:xfrm>
           <a:prstGeom prst="rect">
             <a:avLst/>
@@ -5675,176 +5583,94 @@
       </p:pic>
       <p:sp>
         <p:nvSpPr>
-          <p:cNvPr id="3" name="Etiqueta"/>
-          <p:cNvSpPr txBox="1"/>
-          <p:nvPr/>
-        </p:nvSpPr>
-        <p:spPr>
-          <a:xfrm>
-            <a:off x="243840" y="6370320"/>
-            <a:ext cx="1828800" cy="243840"/>
+          <p:cNvPr id="3" name="Sombra do texto"/>
+          <p:cNvSpPr/>
+          <p:nvPr/>
+        </p:nvSpPr>
+        <p:spPr>
+          <a:xfrm>
+            <a:off x="0" y="4876800"/>
+            <a:ext cx="12192000" cy="1981200"/>
           </a:xfrm>
           <a:prstGeom prst="rect">
             <a:avLst/>
           </a:prstGeom>
           <a:solidFill>
             <a:schemeClr val="tx1">
-              <a:alpha val="60000"/>
+              <a:alpha val="70000"/>
             </a:schemeClr>
           </a:solidFill>
           <a:ln/>
         </p:spPr>
-        <p:txBody>
-          <a:bodyPr wrap="square" lIns="0" tIns="101600" rIns="101600" bIns="0" rtlCol="0" anchor="ctr"/>
-          <a:lstStyle/>
-          <a:p>
-            <a:pPr indent="0" marL="0">
-              <a:buNone/>
-            </a:pPr>
-            <a:r>
-              <a:rPr lang="en-US" sz="800" spc="200" kern="0" dirty="0">
+      </p:sp>
+      <p:sp>
+        <p:nvSpPr>
+          <p:cNvPr id="4" name="Text 0"/>
+          <p:cNvSpPr/>
+          <p:nvPr>
+            <p:ph idx="100" type="body" hasCustomPrompt="1"/>
+          </p:nvPr>
+        </p:nvSpPr>
+        <p:spPr>
+          <a:xfrm>
+            <a:off x="792480" y="5151120"/>
+            <a:ext cx="7620000" cy="182880"/>
+          </a:xfrm>
+          <a:prstGeom prst="rect">
+            <a:avLst/>
+          </a:prstGeom>
+          <a:noFill/>
+          <a:ln/>
+        </p:spPr>
+        <p:txBody>
+          <a:bodyPr wrap="square" lIns="0" tIns="0" rIns="0" bIns="0" rtlCol="0" anchor="t"/>
+          <a:lstStyle/>
+          <a:p>
+            <a:pPr algn="l" indent="0" marL="0">
+              <a:buNone/>
+            </a:pPr>
+            <a:r>
+              <a:rPr lang="en-US" sz="1000" spc="400" kern="0" dirty="0">
+                <a:solidFill>
+                  <a:schemeClr val="accent6"/>
+                </a:solidFill>
+              </a:rPr>
+              <a:t>O PROJETO · 03 / 05</a:t>
+            </a:r>
+            <a:endParaRPr lang="en-US" sz="1000" dirty="0"/>
+          </a:p>
+        </p:txBody>
+      </p:sp>
+      <p:sp>
+        <p:nvSpPr>
+          <p:cNvPr id="5" name="Text 0"/>
+          <p:cNvSpPr/>
+          <p:nvPr>
+            <p:ph idx="101" type="title" hasCustomPrompt="1"/>
+          </p:nvPr>
+        </p:nvSpPr>
+        <p:spPr>
+          <a:xfrm>
+            <a:off x="792480" y="5425440"/>
+            <a:ext cx="7620000" cy="548640"/>
+          </a:xfrm>
+          <a:prstGeom prst="rect">
+            <a:avLst/>
+          </a:prstGeom>
+          <a:noFill/>
+          <a:ln/>
+        </p:spPr>
+        <p:txBody>
+          <a:bodyPr wrap="square" lIns="0" tIns="0" rIns="0" bIns="0" rtlCol="0" anchor="t"/>
+          <a:lstStyle/>
+          <a:p>
+            <a:pPr algn="l" indent="0" marL="0">
+              <a:buNone/>
+            </a:pPr>
+            <a:r>
+              <a:rPr lang="en-US" sz="4000" dirty="0">
                 <a:solidFill>
                   <a:schemeClr val="bg1"/>
-                </a:solidFill>
-              </a:rPr>
-              <a:t>HOJE · FOTO REAL</a:t>
-            </a:r>
-            <a:endParaRPr lang="en-US" sz="800" dirty="0"/>
-          </a:p>
-        </p:txBody>
-      </p:sp>
-      <p:pic>
-        <p:nvPicPr>
-          <p:cNvPr id="4" name="Estúdio de entrevistas: proposta de ambientação" descr="Estúdio de entrevistas: proposta de ambientação">    </p:cNvPr>
-          <p:cNvPicPr>
-            <a:picLocks noChangeAspect="1"/>
-          </p:cNvPicPr>
-          <p:nvPr/>
-        </p:nvPicPr>
-        <p:blipFill>
-          <a:blip r:embed="rId2"/>
-          <a:stretch>
-            <a:fillRect/>
-          </a:stretch>
-        </p:blipFill>
-        <p:spPr>
-          <a:xfrm>
-            <a:off x="4450080" y="670560"/>
-            <a:ext cx="6949440" cy="3909060"/>
-          </a:xfrm>
-          <a:prstGeom prst="rect">
-            <a:avLst/>
-          </a:prstGeom>
-        </p:spPr>
-      </p:pic>
-      <p:sp>
-        <p:nvSpPr>
-          <p:cNvPr id="5" name="Etiqueta"/>
-          <p:cNvSpPr txBox="1"/>
-          <p:nvPr/>
-        </p:nvSpPr>
-        <p:spPr>
-          <a:xfrm>
-            <a:off x="4632960" y="4244340"/>
-            <a:ext cx="3017520" cy="243840"/>
-          </a:xfrm>
-          <a:prstGeom prst="rect">
-            <a:avLst/>
-          </a:prstGeom>
-          <a:solidFill>
-            <a:schemeClr val="tx1">
-              <a:alpha val="60000"/>
-            </a:schemeClr>
-          </a:solidFill>
-          <a:ln/>
-        </p:spPr>
-        <p:txBody>
-          <a:bodyPr wrap="square" lIns="0" tIns="101600" rIns="101600" bIns="0" rtlCol="0" anchor="ctr"/>
-          <a:lstStyle/>
-          <a:p>
-            <a:pPr indent="0" marL="0">
-              <a:buNone/>
-            </a:pPr>
-            <a:r>
-              <a:rPr lang="en-US" sz="800" spc="200" kern="0" dirty="0">
-                <a:solidFill>
-                  <a:schemeClr val="bg1"/>
-                </a:solidFill>
-              </a:rPr>
-              <a:t>PROPOSTA · IMAGEM ILUSTRATIVA</a:t>
-            </a:r>
-            <a:endParaRPr lang="en-US" sz="800" dirty="0"/>
-          </a:p>
-        </p:txBody>
-      </p:sp>
-      <p:sp>
-        <p:nvSpPr>
-          <p:cNvPr id="6" name="Text 0"/>
-          <p:cNvSpPr/>
-          <p:nvPr>
-            <p:ph idx="100" type="body" hasCustomPrompt="1"/>
-          </p:nvPr>
-        </p:nvSpPr>
-        <p:spPr>
-          <a:xfrm>
-            <a:off x="4450080" y="4937760"/>
-            <a:ext cx="6949440" cy="182880"/>
-          </a:xfrm>
-          <a:prstGeom prst="rect">
-            <a:avLst/>
-          </a:prstGeom>
-          <a:noFill/>
-          <a:ln/>
-        </p:spPr>
-        <p:txBody>
-          <a:bodyPr wrap="square" lIns="0" tIns="0" rIns="0" bIns="0" rtlCol="0" anchor="t"/>
-          <a:lstStyle/>
-          <a:p>
-            <a:pPr algn="l" indent="0" marL="0">
-              <a:buNone/>
-            </a:pPr>
-            <a:r>
-              <a:rPr lang="en-US" sz="1000" spc="400" kern="0" dirty="0">
-                <a:solidFill>
-                  <a:schemeClr val="accent2"/>
-                </a:solidFill>
-              </a:rPr>
-              <a:t>ANTES E DEPOIS · 03 / 05</a:t>
-            </a:r>
-            <a:endParaRPr lang="en-US" sz="1000" dirty="0"/>
-          </a:p>
-        </p:txBody>
-      </p:sp>
-      <p:sp>
-        <p:nvSpPr>
-          <p:cNvPr id="7" name="Text 0"/>
-          <p:cNvSpPr/>
-          <p:nvPr>
-            <p:ph idx="101" type="title" hasCustomPrompt="1"/>
-          </p:nvPr>
-        </p:nvSpPr>
-        <p:spPr>
-          <a:xfrm>
-            <a:off x="4450080" y="5181600"/>
-            <a:ext cx="6949440" cy="487680"/>
-          </a:xfrm>
-          <a:prstGeom prst="rect">
-            <a:avLst/>
-          </a:prstGeom>
-          <a:noFill/>
-          <a:ln/>
-        </p:spPr>
-        <p:txBody>
-          <a:bodyPr wrap="square" lIns="0" tIns="0" rIns="0" bIns="0" rtlCol="0" anchor="t"/>
-          <a:lstStyle/>
-          <a:p>
-            <a:pPr algn="l" indent="0" marL="0">
-              <a:buNone/>
-            </a:pPr>
-            <a:r>
-              <a:rPr lang="en-US" sz="3200" dirty="0">
-                <a:solidFill>
-                  <a:schemeClr val="tx1"/>
                 </a:solidFill>
                 <a:latin typeface="Cambria" pitchFamily="34" charset="0"/>
                 <a:ea typeface="Cambria" pitchFamily="34" charset="-122"/>
@@ -5852,20 +5678,20 @@
               </a:rPr>
               <a:t>Estúdio de entrevistas</a:t>
             </a:r>
-            <a:endParaRPr lang="en-US" sz="3200" dirty="0"/>
-          </a:p>
-        </p:txBody>
-      </p:sp>
-      <p:sp>
-        <p:nvSpPr>
-          <p:cNvPr id="8" name="Descrição"/>
+            <a:endParaRPr lang="en-US" sz="4000" dirty="0"/>
+          </a:p>
+        </p:txBody>
+      </p:sp>
+      <p:sp>
+        <p:nvSpPr>
+          <p:cNvPr id="6" name="Descrição"/>
           <p:cNvSpPr txBox="1"/>
           <p:nvPr/>
         </p:nvSpPr>
         <p:spPr>
           <a:xfrm>
-            <a:off x="4450080" y="5730240"/>
-            <a:ext cx="6705600" cy="609600"/>
+            <a:off x="792480" y="6035040"/>
+            <a:ext cx="7620000" cy="457200"/>
           </a:xfrm>
           <a:prstGeom prst="rect">
             <a:avLst/>
@@ -5883,12 +5709,48 @@
             <a:r>
               <a:rPr lang="en-US" sz="1500" dirty="0">
                 <a:solidFill>
-                  <a:schemeClr val="tx2"/>
-                </a:solidFill>
-              </a:rPr>
-              <a:t>A sala com teto preto e vista para a varanda recebe poltronas, microfones e a marca na parede de madeira.</a:t>
+                  <a:schemeClr val="bg1"/>
+                </a:solidFill>
+              </a:rPr>
+              <a:t>Poltronas, microfones e a marca na parede de madeira, com vista para a varanda.</a:t>
             </a:r>
             <a:endParaRPr lang="en-US" sz="1500" dirty="0"/>
+          </a:p>
+        </p:txBody>
+      </p:sp>
+      <p:sp>
+        <p:nvSpPr>
+          <p:cNvPr id="7" name="Aviso"/>
+          <p:cNvSpPr txBox="1"/>
+          <p:nvPr/>
+        </p:nvSpPr>
+        <p:spPr>
+          <a:xfrm>
+            <a:off x="9113520" y="6248400"/>
+            <a:ext cx="2286000" cy="182880"/>
+          </a:xfrm>
+          <a:prstGeom prst="rect">
+            <a:avLst/>
+          </a:prstGeom>
+          <a:noFill/>
+          <a:ln/>
+        </p:spPr>
+        <p:txBody>
+          <a:bodyPr wrap="square" lIns="0" tIns="0" rIns="0" bIns="0" rtlCol="0" anchor="ctr"/>
+          <a:lstStyle/>
+          <a:p>
+            <a:pPr algn="r" indent="0" marL="0">
+              <a:buNone/>
+            </a:pPr>
+            <a:r>
+              <a:rPr lang="en-US" sz="1000" dirty="0">
+                <a:solidFill>
+                  <a:schemeClr val="accent6"/>
+                </a:solidFill>
+              </a:rPr>
+              <a:t>Imagem ilustrativa do projeto</a:t>
+            </a:r>
+            <a:endParaRPr lang="en-US" sz="1000" dirty="0"/>
           </a:p>
         </p:txBody>
       </p:sp>
@@ -5919,7 +5781,7 @@
       </p:grpSpPr>
       <p:pic>
         <p:nvPicPr>
-          <p:cNvPr id="2" name="Sala de cursos: foto real hoje" descr="Sala de cursos: foto real hoje">    </p:cNvPr>
+          <p:cNvPr id="2" name="Sala de cursos: projeto de ambientação" descr="Sala de cursos: projeto de ambientação">    </p:cNvPr>
           <p:cNvPicPr>
             <a:picLocks noChangeAspect="1"/>
           </p:cNvPicPr>
@@ -5934,7 +5796,7 @@
         <p:spPr>
           <a:xfrm>
             <a:off x="0" y="0"/>
-            <a:ext cx="3962400" cy="6858000"/>
+            <a:ext cx="12192000" cy="6858000"/>
           </a:xfrm>
           <a:prstGeom prst="rect">
             <a:avLst/>
@@ -5943,176 +5805,94 @@
       </p:pic>
       <p:sp>
         <p:nvSpPr>
-          <p:cNvPr id="3" name="Etiqueta"/>
-          <p:cNvSpPr txBox="1"/>
-          <p:nvPr/>
-        </p:nvSpPr>
-        <p:spPr>
-          <a:xfrm>
-            <a:off x="243840" y="6370320"/>
-            <a:ext cx="1828800" cy="243840"/>
+          <p:cNvPr id="3" name="Sombra do texto"/>
+          <p:cNvSpPr/>
+          <p:nvPr/>
+        </p:nvSpPr>
+        <p:spPr>
+          <a:xfrm>
+            <a:off x="0" y="4876800"/>
+            <a:ext cx="12192000" cy="1981200"/>
           </a:xfrm>
           <a:prstGeom prst="rect">
             <a:avLst/>
           </a:prstGeom>
           <a:solidFill>
             <a:schemeClr val="tx1">
-              <a:alpha val="60000"/>
+              <a:alpha val="70000"/>
             </a:schemeClr>
           </a:solidFill>
           <a:ln/>
         </p:spPr>
-        <p:txBody>
-          <a:bodyPr wrap="square" lIns="0" tIns="101600" rIns="101600" bIns="0" rtlCol="0" anchor="ctr"/>
-          <a:lstStyle/>
-          <a:p>
-            <a:pPr indent="0" marL="0">
-              <a:buNone/>
-            </a:pPr>
-            <a:r>
-              <a:rPr lang="en-US" sz="800" spc="200" kern="0" dirty="0">
+      </p:sp>
+      <p:sp>
+        <p:nvSpPr>
+          <p:cNvPr id="4" name="Text 0"/>
+          <p:cNvSpPr/>
+          <p:nvPr>
+            <p:ph idx="100" type="body" hasCustomPrompt="1"/>
+          </p:nvPr>
+        </p:nvSpPr>
+        <p:spPr>
+          <a:xfrm>
+            <a:off x="792480" y="5151120"/>
+            <a:ext cx="7620000" cy="182880"/>
+          </a:xfrm>
+          <a:prstGeom prst="rect">
+            <a:avLst/>
+          </a:prstGeom>
+          <a:noFill/>
+          <a:ln/>
+        </p:spPr>
+        <p:txBody>
+          <a:bodyPr wrap="square" lIns="0" tIns="0" rIns="0" bIns="0" rtlCol="0" anchor="t"/>
+          <a:lstStyle/>
+          <a:p>
+            <a:pPr algn="l" indent="0" marL="0">
+              <a:buNone/>
+            </a:pPr>
+            <a:r>
+              <a:rPr lang="en-US" sz="1000" spc="400" kern="0" dirty="0">
+                <a:solidFill>
+                  <a:schemeClr val="accent6"/>
+                </a:solidFill>
+              </a:rPr>
+              <a:t>O PROJETO · 04 / 05</a:t>
+            </a:r>
+            <a:endParaRPr lang="en-US" sz="1000" dirty="0"/>
+          </a:p>
+        </p:txBody>
+      </p:sp>
+      <p:sp>
+        <p:nvSpPr>
+          <p:cNvPr id="5" name="Text 0"/>
+          <p:cNvSpPr/>
+          <p:nvPr>
+            <p:ph idx="101" type="title" hasCustomPrompt="1"/>
+          </p:nvPr>
+        </p:nvSpPr>
+        <p:spPr>
+          <a:xfrm>
+            <a:off x="792480" y="5425440"/>
+            <a:ext cx="7620000" cy="548640"/>
+          </a:xfrm>
+          <a:prstGeom prst="rect">
+            <a:avLst/>
+          </a:prstGeom>
+          <a:noFill/>
+          <a:ln/>
+        </p:spPr>
+        <p:txBody>
+          <a:bodyPr wrap="square" lIns="0" tIns="0" rIns="0" bIns="0" rtlCol="0" anchor="t"/>
+          <a:lstStyle/>
+          <a:p>
+            <a:pPr algn="l" indent="0" marL="0">
+              <a:buNone/>
+            </a:pPr>
+            <a:r>
+              <a:rPr lang="en-US" sz="4000" dirty="0">
                 <a:solidFill>
                   <a:schemeClr val="bg1"/>
-                </a:solidFill>
-              </a:rPr>
-              <a:t>HOJE · FOTO REAL</a:t>
-            </a:r>
-            <a:endParaRPr lang="en-US" sz="800" dirty="0"/>
-          </a:p>
-        </p:txBody>
-      </p:sp>
-      <p:pic>
-        <p:nvPicPr>
-          <p:cNvPr id="4" name="Sala de cursos: proposta de ambientação" descr="Sala de cursos: proposta de ambientação">    </p:cNvPr>
-          <p:cNvPicPr>
-            <a:picLocks noChangeAspect="1"/>
-          </p:cNvPicPr>
-          <p:nvPr/>
-        </p:nvPicPr>
-        <p:blipFill>
-          <a:blip r:embed="rId2"/>
-          <a:stretch>
-            <a:fillRect/>
-          </a:stretch>
-        </p:blipFill>
-        <p:spPr>
-          <a:xfrm>
-            <a:off x="4450080" y="670560"/>
-            <a:ext cx="6949440" cy="3909060"/>
-          </a:xfrm>
-          <a:prstGeom prst="rect">
-            <a:avLst/>
-          </a:prstGeom>
-        </p:spPr>
-      </p:pic>
-      <p:sp>
-        <p:nvSpPr>
-          <p:cNvPr id="5" name="Etiqueta"/>
-          <p:cNvSpPr txBox="1"/>
-          <p:nvPr/>
-        </p:nvSpPr>
-        <p:spPr>
-          <a:xfrm>
-            <a:off x="4632960" y="4244340"/>
-            <a:ext cx="3017520" cy="243840"/>
-          </a:xfrm>
-          <a:prstGeom prst="rect">
-            <a:avLst/>
-          </a:prstGeom>
-          <a:solidFill>
-            <a:schemeClr val="tx1">
-              <a:alpha val="60000"/>
-            </a:schemeClr>
-          </a:solidFill>
-          <a:ln/>
-        </p:spPr>
-        <p:txBody>
-          <a:bodyPr wrap="square" lIns="0" tIns="101600" rIns="101600" bIns="0" rtlCol="0" anchor="ctr"/>
-          <a:lstStyle/>
-          <a:p>
-            <a:pPr indent="0" marL="0">
-              <a:buNone/>
-            </a:pPr>
-            <a:r>
-              <a:rPr lang="en-US" sz="800" spc="200" kern="0" dirty="0">
-                <a:solidFill>
-                  <a:schemeClr val="bg1"/>
-                </a:solidFill>
-              </a:rPr>
-              <a:t>PROPOSTA · IMAGEM ILUSTRATIVA</a:t>
-            </a:r>
-            <a:endParaRPr lang="en-US" sz="800" dirty="0"/>
-          </a:p>
-        </p:txBody>
-      </p:sp>
-      <p:sp>
-        <p:nvSpPr>
-          <p:cNvPr id="6" name="Text 0"/>
-          <p:cNvSpPr/>
-          <p:nvPr>
-            <p:ph idx="100" type="body" hasCustomPrompt="1"/>
-          </p:nvPr>
-        </p:nvSpPr>
-        <p:spPr>
-          <a:xfrm>
-            <a:off x="4450080" y="4937760"/>
-            <a:ext cx="6949440" cy="182880"/>
-          </a:xfrm>
-          <a:prstGeom prst="rect">
-            <a:avLst/>
-          </a:prstGeom>
-          <a:noFill/>
-          <a:ln/>
-        </p:spPr>
-        <p:txBody>
-          <a:bodyPr wrap="square" lIns="0" tIns="0" rIns="0" bIns="0" rtlCol="0" anchor="t"/>
-          <a:lstStyle/>
-          <a:p>
-            <a:pPr algn="l" indent="0" marL="0">
-              <a:buNone/>
-            </a:pPr>
-            <a:r>
-              <a:rPr lang="en-US" sz="1000" spc="400" kern="0" dirty="0">
-                <a:solidFill>
-                  <a:schemeClr val="accent2"/>
-                </a:solidFill>
-              </a:rPr>
-              <a:t>ANTES E DEPOIS · 04 / 05</a:t>
-            </a:r>
-            <a:endParaRPr lang="en-US" sz="1000" dirty="0"/>
-          </a:p>
-        </p:txBody>
-      </p:sp>
-      <p:sp>
-        <p:nvSpPr>
-          <p:cNvPr id="7" name="Text 0"/>
-          <p:cNvSpPr/>
-          <p:nvPr>
-            <p:ph idx="101" type="title" hasCustomPrompt="1"/>
-          </p:nvPr>
-        </p:nvSpPr>
-        <p:spPr>
-          <a:xfrm>
-            <a:off x="4450080" y="5181600"/>
-            <a:ext cx="6949440" cy="487680"/>
-          </a:xfrm>
-          <a:prstGeom prst="rect">
-            <a:avLst/>
-          </a:prstGeom>
-          <a:noFill/>
-          <a:ln/>
-        </p:spPr>
-        <p:txBody>
-          <a:bodyPr wrap="square" lIns="0" tIns="0" rIns="0" bIns="0" rtlCol="0" anchor="t"/>
-          <a:lstStyle/>
-          <a:p>
-            <a:pPr algn="l" indent="0" marL="0">
-              <a:buNone/>
-            </a:pPr>
-            <a:r>
-              <a:rPr lang="en-US" sz="3200" dirty="0">
-                <a:solidFill>
-                  <a:schemeClr val="tx1"/>
                 </a:solidFill>
                 <a:latin typeface="Cambria" pitchFamily="34" charset="0"/>
                 <a:ea typeface="Cambria" pitchFamily="34" charset="-122"/>
@@ -6120,20 +5900,20 @@
               </a:rPr>
               <a:t>Sala de cursos</a:t>
             </a:r>
-            <a:endParaRPr lang="en-US" sz="3200" dirty="0"/>
-          </a:p>
-        </p:txBody>
-      </p:sp>
-      <p:sp>
-        <p:nvSpPr>
-          <p:cNvPr id="8" name="Descrição"/>
+            <a:endParaRPr lang="en-US" sz="4000" dirty="0"/>
+          </a:p>
+        </p:txBody>
+      </p:sp>
+      <p:sp>
+        <p:nvSpPr>
+          <p:cNvPr id="6" name="Descrição"/>
           <p:cNvSpPr txBox="1"/>
           <p:nvPr/>
         </p:nvSpPr>
         <p:spPr>
           <a:xfrm>
-            <a:off x="4450080" y="5730240"/>
-            <a:ext cx="6705600" cy="609600"/>
+            <a:off x="792480" y="6035040"/>
+            <a:ext cx="7620000" cy="457200"/>
           </a:xfrm>
           <a:prstGeom prst="rect">
             <a:avLst/>
@@ -6151,12 +5931,48 @@
             <a:r>
               <a:rPr lang="en-US" sz="1500" dirty="0">
                 <a:solidFill>
-                  <a:schemeClr val="tx2"/>
-                </a:solidFill>
-              </a:rPr>
-              <a:t>O salão amplo comporta plateia, tela e bancada de demonstração para os cursos educacionais mensais.</a:t>
+                  <a:schemeClr val="bg1"/>
+                </a:solidFill>
+              </a:rPr>
+              <a:t>Plateia, tela e bancada de demonstração para os cursos educacionais mensais.</a:t>
             </a:r>
             <a:endParaRPr lang="en-US" sz="1500" dirty="0"/>
+          </a:p>
+        </p:txBody>
+      </p:sp>
+      <p:sp>
+        <p:nvSpPr>
+          <p:cNvPr id="7" name="Aviso"/>
+          <p:cNvSpPr txBox="1"/>
+          <p:nvPr/>
+        </p:nvSpPr>
+        <p:spPr>
+          <a:xfrm>
+            <a:off x="9113520" y="6248400"/>
+            <a:ext cx="2286000" cy="182880"/>
+          </a:xfrm>
+          <a:prstGeom prst="rect">
+            <a:avLst/>
+          </a:prstGeom>
+          <a:noFill/>
+          <a:ln/>
+        </p:spPr>
+        <p:txBody>
+          <a:bodyPr wrap="square" lIns="0" tIns="0" rIns="0" bIns="0" rtlCol="0" anchor="ctr"/>
+          <a:lstStyle/>
+          <a:p>
+            <a:pPr algn="r" indent="0" marL="0">
+              <a:buNone/>
+            </a:pPr>
+            <a:r>
+              <a:rPr lang="en-US" sz="1000" dirty="0">
+                <a:solidFill>
+                  <a:schemeClr val="accent6"/>
+                </a:solidFill>
+              </a:rPr>
+              <a:t>Imagem ilustrativa do projeto</a:t>
+            </a:r>
+            <a:endParaRPr lang="en-US" sz="1000" dirty="0"/>
           </a:p>
         </p:txBody>
       </p:sp>
@@ -6187,7 +6003,7 @@
       </p:grpSpPr>
       <p:pic>
         <p:nvPicPr>
-          <p:cNvPr id="2" name="Área de eventos: foto real hoje" descr="Área de eventos: foto real hoje">    </p:cNvPr>
+          <p:cNvPr id="2" name="Área de eventos: projeto de ambientação" descr="Área de eventos: projeto de ambientação">    </p:cNvPr>
           <p:cNvPicPr>
             <a:picLocks noChangeAspect="1"/>
           </p:cNvPicPr>
@@ -6202,7 +6018,7 @@
         <p:spPr>
           <a:xfrm>
             <a:off x="0" y="0"/>
-            <a:ext cx="3962400" cy="6858000"/>
+            <a:ext cx="12192000" cy="6858000"/>
           </a:xfrm>
           <a:prstGeom prst="rect">
             <a:avLst/>
@@ -6211,176 +6027,94 @@
       </p:pic>
       <p:sp>
         <p:nvSpPr>
-          <p:cNvPr id="3" name="Etiqueta"/>
-          <p:cNvSpPr txBox="1"/>
-          <p:nvPr/>
-        </p:nvSpPr>
-        <p:spPr>
-          <a:xfrm>
-            <a:off x="243840" y="6370320"/>
-            <a:ext cx="1828800" cy="243840"/>
+          <p:cNvPr id="3" name="Sombra do texto"/>
+          <p:cNvSpPr/>
+          <p:nvPr/>
+        </p:nvSpPr>
+        <p:spPr>
+          <a:xfrm>
+            <a:off x="0" y="4876800"/>
+            <a:ext cx="12192000" cy="1981200"/>
           </a:xfrm>
           <a:prstGeom prst="rect">
             <a:avLst/>
           </a:prstGeom>
           <a:solidFill>
             <a:schemeClr val="tx1">
-              <a:alpha val="60000"/>
+              <a:alpha val="70000"/>
             </a:schemeClr>
           </a:solidFill>
           <a:ln/>
         </p:spPr>
-        <p:txBody>
-          <a:bodyPr wrap="square" lIns="0" tIns="101600" rIns="101600" bIns="0" rtlCol="0" anchor="ctr"/>
-          <a:lstStyle/>
-          <a:p>
-            <a:pPr indent="0" marL="0">
-              <a:buNone/>
-            </a:pPr>
-            <a:r>
-              <a:rPr lang="en-US" sz="800" spc="200" kern="0" dirty="0">
+      </p:sp>
+      <p:sp>
+        <p:nvSpPr>
+          <p:cNvPr id="4" name="Text 0"/>
+          <p:cNvSpPr/>
+          <p:nvPr>
+            <p:ph idx="100" type="body" hasCustomPrompt="1"/>
+          </p:nvPr>
+        </p:nvSpPr>
+        <p:spPr>
+          <a:xfrm>
+            <a:off x="792480" y="5151120"/>
+            <a:ext cx="7620000" cy="182880"/>
+          </a:xfrm>
+          <a:prstGeom prst="rect">
+            <a:avLst/>
+          </a:prstGeom>
+          <a:noFill/>
+          <a:ln/>
+        </p:spPr>
+        <p:txBody>
+          <a:bodyPr wrap="square" lIns="0" tIns="0" rIns="0" bIns="0" rtlCol="0" anchor="t"/>
+          <a:lstStyle/>
+          <a:p>
+            <a:pPr algn="l" indent="0" marL="0">
+              <a:buNone/>
+            </a:pPr>
+            <a:r>
+              <a:rPr lang="en-US" sz="1000" spc="400" kern="0" dirty="0">
+                <a:solidFill>
+                  <a:schemeClr val="accent6"/>
+                </a:solidFill>
+              </a:rPr>
+              <a:t>O PROJETO · 05 / 05</a:t>
+            </a:r>
+            <a:endParaRPr lang="en-US" sz="1000" dirty="0"/>
+          </a:p>
+        </p:txBody>
+      </p:sp>
+      <p:sp>
+        <p:nvSpPr>
+          <p:cNvPr id="5" name="Text 0"/>
+          <p:cNvSpPr/>
+          <p:nvPr>
+            <p:ph idx="101" type="title" hasCustomPrompt="1"/>
+          </p:nvPr>
+        </p:nvSpPr>
+        <p:spPr>
+          <a:xfrm>
+            <a:off x="792480" y="5425440"/>
+            <a:ext cx="7620000" cy="548640"/>
+          </a:xfrm>
+          <a:prstGeom prst="rect">
+            <a:avLst/>
+          </a:prstGeom>
+          <a:noFill/>
+          <a:ln/>
+        </p:spPr>
+        <p:txBody>
+          <a:bodyPr wrap="square" lIns="0" tIns="0" rIns="0" bIns="0" rtlCol="0" anchor="t"/>
+          <a:lstStyle/>
+          <a:p>
+            <a:pPr algn="l" indent="0" marL="0">
+              <a:buNone/>
+            </a:pPr>
+            <a:r>
+              <a:rPr lang="en-US" sz="4000" dirty="0">
                 <a:solidFill>
                   <a:schemeClr val="bg1"/>
-                </a:solidFill>
-              </a:rPr>
-              <a:t>HOJE · FOTO REAL</a:t>
-            </a:r>
-            <a:endParaRPr lang="en-US" sz="800" dirty="0"/>
-          </a:p>
-        </p:txBody>
-      </p:sp>
-      <p:pic>
-        <p:nvPicPr>
-          <p:cNvPr id="4" name="Área de eventos: proposta de ambientação" descr="Área de eventos: proposta de ambientação">    </p:cNvPr>
-          <p:cNvPicPr>
-            <a:picLocks noChangeAspect="1"/>
-          </p:cNvPicPr>
-          <p:nvPr/>
-        </p:nvPicPr>
-        <p:blipFill>
-          <a:blip r:embed="rId2"/>
-          <a:stretch>
-            <a:fillRect/>
-          </a:stretch>
-        </p:blipFill>
-        <p:spPr>
-          <a:xfrm>
-            <a:off x="4450080" y="670560"/>
-            <a:ext cx="6949440" cy="3909060"/>
-          </a:xfrm>
-          <a:prstGeom prst="rect">
-            <a:avLst/>
-          </a:prstGeom>
-        </p:spPr>
-      </p:pic>
-      <p:sp>
-        <p:nvSpPr>
-          <p:cNvPr id="5" name="Etiqueta"/>
-          <p:cNvSpPr txBox="1"/>
-          <p:nvPr/>
-        </p:nvSpPr>
-        <p:spPr>
-          <a:xfrm>
-            <a:off x="4632960" y="4244340"/>
-            <a:ext cx="3017520" cy="243840"/>
-          </a:xfrm>
-          <a:prstGeom prst="rect">
-            <a:avLst/>
-          </a:prstGeom>
-          <a:solidFill>
-            <a:schemeClr val="tx1">
-              <a:alpha val="60000"/>
-            </a:schemeClr>
-          </a:solidFill>
-          <a:ln/>
-        </p:spPr>
-        <p:txBody>
-          <a:bodyPr wrap="square" lIns="0" tIns="101600" rIns="101600" bIns="0" rtlCol="0" anchor="ctr"/>
-          <a:lstStyle/>
-          <a:p>
-            <a:pPr indent="0" marL="0">
-              <a:buNone/>
-            </a:pPr>
-            <a:r>
-              <a:rPr lang="en-US" sz="800" spc="200" kern="0" dirty="0">
-                <a:solidFill>
-                  <a:schemeClr val="bg1"/>
-                </a:solidFill>
-              </a:rPr>
-              <a:t>PROPOSTA · IMAGEM ILUSTRATIVA</a:t>
-            </a:r>
-            <a:endParaRPr lang="en-US" sz="800" dirty="0"/>
-          </a:p>
-        </p:txBody>
-      </p:sp>
-      <p:sp>
-        <p:nvSpPr>
-          <p:cNvPr id="6" name="Text 0"/>
-          <p:cNvSpPr/>
-          <p:nvPr>
-            <p:ph idx="100" type="body" hasCustomPrompt="1"/>
-          </p:nvPr>
-        </p:nvSpPr>
-        <p:spPr>
-          <a:xfrm>
-            <a:off x="4450080" y="4937760"/>
-            <a:ext cx="6949440" cy="182880"/>
-          </a:xfrm>
-          <a:prstGeom prst="rect">
-            <a:avLst/>
-          </a:prstGeom>
-          <a:noFill/>
-          <a:ln/>
-        </p:spPr>
-        <p:txBody>
-          <a:bodyPr wrap="square" lIns="0" tIns="0" rIns="0" bIns="0" rtlCol="0" anchor="t"/>
-          <a:lstStyle/>
-          <a:p>
-            <a:pPr algn="l" indent="0" marL="0">
-              <a:buNone/>
-            </a:pPr>
-            <a:r>
-              <a:rPr lang="en-US" sz="1000" spc="400" kern="0" dirty="0">
-                <a:solidFill>
-                  <a:schemeClr val="accent2"/>
-                </a:solidFill>
-              </a:rPr>
-              <a:t>ANTES E DEPOIS · 05 / 05</a:t>
-            </a:r>
-            <a:endParaRPr lang="en-US" sz="1000" dirty="0"/>
-          </a:p>
-        </p:txBody>
-      </p:sp>
-      <p:sp>
-        <p:nvSpPr>
-          <p:cNvPr id="7" name="Text 0"/>
-          <p:cNvSpPr/>
-          <p:nvPr>
-            <p:ph idx="101" type="title" hasCustomPrompt="1"/>
-          </p:nvPr>
-        </p:nvSpPr>
-        <p:spPr>
-          <a:xfrm>
-            <a:off x="4450080" y="5181600"/>
-            <a:ext cx="6949440" cy="487680"/>
-          </a:xfrm>
-          <a:prstGeom prst="rect">
-            <a:avLst/>
-          </a:prstGeom>
-          <a:noFill/>
-          <a:ln/>
-        </p:spPr>
-        <p:txBody>
-          <a:bodyPr wrap="square" lIns="0" tIns="0" rIns="0" bIns="0" rtlCol="0" anchor="t"/>
-          <a:lstStyle/>
-          <a:p>
-            <a:pPr algn="l" indent="0" marL="0">
-              <a:buNone/>
-            </a:pPr>
-            <a:r>
-              <a:rPr lang="en-US" sz="3200" dirty="0">
-                <a:solidFill>
-                  <a:schemeClr val="tx1"/>
                 </a:solidFill>
                 <a:latin typeface="Cambria" pitchFamily="34" charset="0"/>
                 <a:ea typeface="Cambria" pitchFamily="34" charset="-122"/>
@@ -6388,20 +6122,20 @@
               </a:rPr>
               <a:t>Área de eventos</a:t>
             </a:r>
-            <a:endParaRPr lang="en-US" sz="3200" dirty="0"/>
-          </a:p>
-        </p:txBody>
-      </p:sp>
-      <p:sp>
-        <p:nvSpPr>
-          <p:cNvPr id="8" name="Descrição"/>
+            <a:endParaRPr lang="en-US" sz="4000" dirty="0"/>
+          </a:p>
+        </p:txBody>
+      </p:sp>
+      <p:sp>
+        <p:nvSpPr>
+          <p:cNvPr id="6" name="Descrição"/>
           <p:cNvSpPr txBox="1"/>
           <p:nvPr/>
         </p:nvSpPr>
         <p:spPr>
           <a:xfrm>
-            <a:off x="4450080" y="5730240"/>
-            <a:ext cx="6705600" cy="609600"/>
+            <a:off x="792480" y="6035040"/>
+            <a:ext cx="7620000" cy="457200"/>
           </a:xfrm>
           <a:prstGeom prst="rect">
             <a:avLst/>
@@ -6419,12 +6153,48 @@
             <a:r>
               <a:rPr lang="en-US" sz="1500" dirty="0">
                 <a:solidFill>
-                  <a:schemeClr val="tx2"/>
-                </a:solidFill>
-              </a:rPr>
-              <a:t>A piscina e o muro do fundo viram palco para lançamentos, com espreguiçadeiras, iluminação e mesa de produtos.</a:t>
+                  <a:schemeClr val="bg1"/>
+                </a:solidFill>
+              </a:rPr>
+              <a:t>A piscina vira palco para lançamentos, com espreguiçadeiras, iluminação e mesa de produtos.</a:t>
             </a:r>
             <a:endParaRPr lang="en-US" sz="1500" dirty="0"/>
+          </a:p>
+        </p:txBody>
+      </p:sp>
+      <p:sp>
+        <p:nvSpPr>
+          <p:cNvPr id="7" name="Aviso"/>
+          <p:cNvSpPr txBox="1"/>
+          <p:nvPr/>
+        </p:nvSpPr>
+        <p:spPr>
+          <a:xfrm>
+            <a:off x="9113520" y="6248400"/>
+            <a:ext cx="2286000" cy="182880"/>
+          </a:xfrm>
+          <a:prstGeom prst="rect">
+            <a:avLst/>
+          </a:prstGeom>
+          <a:noFill/>
+          <a:ln/>
+        </p:spPr>
+        <p:txBody>
+          <a:bodyPr wrap="square" lIns="0" tIns="0" rIns="0" bIns="0" rtlCol="0" anchor="ctr"/>
+          <a:lstStyle/>
+          <a:p>
+            <a:pPr algn="r" indent="0" marL="0">
+              <a:buNone/>
+            </a:pPr>
+            <a:r>
+              <a:rPr lang="en-US" sz="1000" dirty="0">
+                <a:solidFill>
+                  <a:schemeClr val="accent6"/>
+                </a:solidFill>
+              </a:rPr>
+              <a:t>Imagem ilustrativa do projeto</a:t>
+            </a:r>
+            <a:endParaRPr lang="en-US" sz="1000" dirty="0"/>
           </a:p>
         </p:txBody>
       </p:sp>

</xml_diff>